<commit_message>
Fix parsers and add .pdf file
</commit_message>
<xml_diff>
--- a/UMIRHack Blumenkohl.pptx
+++ b/UMIRHack Blumenkohl.pptx
@@ -9,8 +9,9 @@
     <p:sldId id="260" r:id="rId3"/>
     <p:sldId id="261" r:id="rId4"/>
     <p:sldId id="258" r:id="rId5"/>
-    <p:sldId id="259" r:id="rId6"/>
-    <p:sldId id="256" r:id="rId7"/>
+    <p:sldId id="262" r:id="rId6"/>
+    <p:sldId id="259" r:id="rId7"/>
+    <p:sldId id="256" r:id="rId8"/>
   </p:sldIdLst>
   <p:sldSz cx="12192000" cy="6858000"/>
   <p:notesSz cx="6858000" cy="9144000"/>
@@ -109,6 +110,11 @@
       </a:defRPr>
     </a:lvl9pPr>
   </p:defaultTextStyle>
+  <p:extLst>
+    <p:ext uri="{EFAFB233-063F-42B5-8137-9DF3F51BA10A}">
+      <p15:sldGuideLst xmlns:p15="http://schemas.microsoft.com/office/powerpoint/2012/main"/>
+    </p:ext>
+  </p:extLst>
 </p:presentation>
 </file>
 
@@ -259,7 +265,7 @@
           <a:p>
             <a:fld id="{95F6E378-5AF7-4AE6-8A41-882E0303B821}" type="datetimeFigureOut">
               <a:rPr lang="ru-RU" smtClean="0"/>
-              <a:t>04.04.2026</a:t>
+              <a:t>05.04.2026</a:t>
             </a:fld>
             <a:endParaRPr lang="ru-RU"/>
           </a:p>
@@ -457,7 +463,7 @@
           <a:p>
             <a:fld id="{95F6E378-5AF7-4AE6-8A41-882E0303B821}" type="datetimeFigureOut">
               <a:rPr lang="ru-RU" smtClean="0"/>
-              <a:t>04.04.2026</a:t>
+              <a:t>05.04.2026</a:t>
             </a:fld>
             <a:endParaRPr lang="ru-RU"/>
           </a:p>
@@ -665,7 +671,7 @@
           <a:p>
             <a:fld id="{95F6E378-5AF7-4AE6-8A41-882E0303B821}" type="datetimeFigureOut">
               <a:rPr lang="ru-RU" smtClean="0"/>
-              <a:t>04.04.2026</a:t>
+              <a:t>05.04.2026</a:t>
             </a:fld>
             <a:endParaRPr lang="ru-RU"/>
           </a:p>
@@ -863,7 +869,7 @@
           <a:p>
             <a:fld id="{95F6E378-5AF7-4AE6-8A41-882E0303B821}" type="datetimeFigureOut">
               <a:rPr lang="ru-RU" smtClean="0"/>
-              <a:t>04.04.2026</a:t>
+              <a:t>05.04.2026</a:t>
             </a:fld>
             <a:endParaRPr lang="ru-RU"/>
           </a:p>
@@ -1138,7 +1144,7 @@
           <a:p>
             <a:fld id="{95F6E378-5AF7-4AE6-8A41-882E0303B821}" type="datetimeFigureOut">
               <a:rPr lang="ru-RU" smtClean="0"/>
-              <a:t>04.04.2026</a:t>
+              <a:t>05.04.2026</a:t>
             </a:fld>
             <a:endParaRPr lang="ru-RU"/>
           </a:p>
@@ -1403,7 +1409,7 @@
           <a:p>
             <a:fld id="{95F6E378-5AF7-4AE6-8A41-882E0303B821}" type="datetimeFigureOut">
               <a:rPr lang="ru-RU" smtClean="0"/>
-              <a:t>04.04.2026</a:t>
+              <a:t>05.04.2026</a:t>
             </a:fld>
             <a:endParaRPr lang="ru-RU"/>
           </a:p>
@@ -1815,7 +1821,7 @@
           <a:p>
             <a:fld id="{95F6E378-5AF7-4AE6-8A41-882E0303B821}" type="datetimeFigureOut">
               <a:rPr lang="ru-RU" smtClean="0"/>
-              <a:t>04.04.2026</a:t>
+              <a:t>05.04.2026</a:t>
             </a:fld>
             <a:endParaRPr lang="ru-RU"/>
           </a:p>
@@ -1956,7 +1962,7 @@
           <a:p>
             <a:fld id="{95F6E378-5AF7-4AE6-8A41-882E0303B821}" type="datetimeFigureOut">
               <a:rPr lang="ru-RU" smtClean="0"/>
-              <a:t>04.04.2026</a:t>
+              <a:t>05.04.2026</a:t>
             </a:fld>
             <a:endParaRPr lang="ru-RU"/>
           </a:p>
@@ -2069,7 +2075,7 @@
           <a:p>
             <a:fld id="{95F6E378-5AF7-4AE6-8A41-882E0303B821}" type="datetimeFigureOut">
               <a:rPr lang="ru-RU" smtClean="0"/>
-              <a:t>04.04.2026</a:t>
+              <a:t>05.04.2026</a:t>
             </a:fld>
             <a:endParaRPr lang="ru-RU"/>
           </a:p>
@@ -2380,7 +2386,7 @@
           <a:p>
             <a:fld id="{95F6E378-5AF7-4AE6-8A41-882E0303B821}" type="datetimeFigureOut">
               <a:rPr lang="ru-RU" smtClean="0"/>
-              <a:t>04.04.2026</a:t>
+              <a:t>05.04.2026</a:t>
             </a:fld>
             <a:endParaRPr lang="ru-RU"/>
           </a:p>
@@ -2668,7 +2674,7 @@
           <a:p>
             <a:fld id="{95F6E378-5AF7-4AE6-8A41-882E0303B821}" type="datetimeFigureOut">
               <a:rPr lang="ru-RU" smtClean="0"/>
-              <a:t>04.04.2026</a:t>
+              <a:t>05.04.2026</a:t>
             </a:fld>
             <a:endParaRPr lang="ru-RU"/>
           </a:p>
@@ -2909,7 +2915,7 @@
           <a:p>
             <a:fld id="{95F6E378-5AF7-4AE6-8A41-882E0303B821}" type="datetimeFigureOut">
               <a:rPr lang="ru-RU" smtClean="0"/>
-              <a:t>04.04.2026</a:t>
+              <a:t>05.04.2026</a:t>
             </a:fld>
             <a:endParaRPr lang="ru-RU"/>
           </a:p>
@@ -3900,7 +3906,7 @@
         </p:nvSpPr>
         <p:spPr>
           <a:xfrm>
-            <a:off x="8590546" y="378034"/>
+            <a:off x="8141368" y="432103"/>
             <a:ext cx="3481137" cy="569495"/>
           </a:xfrm>
           <a:prstGeom prst="roundRect">
@@ -4553,6 +4559,704 @@
       </p:grpSpPr>
       <p:sp>
         <p:nvSpPr>
+          <p:cNvPr id="2" name="Заголовок 1">
+            <a:extLst>
+              <a:ext uri="{FF2B5EF4-FFF2-40B4-BE49-F238E27FC236}">
+                <a16:creationId xmlns:a16="http://schemas.microsoft.com/office/drawing/2014/main" id="{6D157E61-5114-4200-893C-683F70606D89}"/>
+              </a:ext>
+            </a:extLst>
+          </p:cNvPr>
+          <p:cNvSpPr>
+            <a:spLocks noGrp="1"/>
+          </p:cNvSpPr>
+          <p:nvPr>
+            <p:ph type="title"/>
+          </p:nvPr>
+        </p:nvSpPr>
+        <p:spPr>
+          <a:xfrm>
+            <a:off x="0" y="0"/>
+            <a:ext cx="10515600" cy="1325563"/>
+          </a:xfrm>
+        </p:spPr>
+        <p:txBody>
+          <a:bodyPr/>
+          <a:lstStyle/>
+          <a:p>
+            <a:r>
+              <a:rPr lang="ru-RU" dirty="0">
+                <a:latin typeface="Roboto" panose="02000000000000000000" pitchFamily="2" charset="0"/>
+                <a:ea typeface="Roboto" panose="02000000000000000000" pitchFamily="2" charset="0"/>
+              </a:rPr>
+              <a:t>Основные технологии</a:t>
+            </a:r>
+          </a:p>
+        </p:txBody>
+      </p:sp>
+      <p:sp>
+        <p:nvSpPr>
+          <p:cNvPr id="11" name="TextBox 10">
+            <a:extLst>
+              <a:ext uri="{FF2B5EF4-FFF2-40B4-BE49-F238E27FC236}">
+                <a16:creationId xmlns:a16="http://schemas.microsoft.com/office/drawing/2014/main" id="{21A8B898-DF60-4379-B498-E4E23AB93558}"/>
+              </a:ext>
+            </a:extLst>
+          </p:cNvPr>
+          <p:cNvSpPr txBox="1"/>
+          <p:nvPr/>
+        </p:nvSpPr>
+        <p:spPr>
+          <a:xfrm>
+            <a:off x="366961" y="1639867"/>
+            <a:ext cx="4076702" cy="2031325"/>
+          </a:xfrm>
+          <a:prstGeom prst="rect">
+            <a:avLst/>
+          </a:prstGeom>
+          <a:noFill/>
+        </p:spPr>
+        <p:txBody>
+          <a:bodyPr wrap="square">
+            <a:spAutoFit/>
+          </a:bodyPr>
+          <a:lstStyle/>
+          <a:p>
+            <a:pPr algn="just"/>
+            <a:br>
+              <a:rPr lang="ru-RU" b="1" i="0" dirty="0">
+                <a:effectLst/>
+                <a:latin typeface="Roboto" panose="02000000000000000000" pitchFamily="2" charset="0"/>
+                <a:ea typeface="Roboto" panose="02000000000000000000" pitchFamily="2" charset="0"/>
+              </a:rPr>
+            </a:br>
+            <a:r>
+              <a:rPr lang="en-US" b="1" i="0" dirty="0">
+                <a:effectLst/>
+                <a:latin typeface="Roboto" panose="02000000000000000000" pitchFamily="2" charset="0"/>
+                <a:ea typeface="Roboto" panose="02000000000000000000" pitchFamily="2" charset="0"/>
+              </a:rPr>
+              <a:t>VK API </a:t>
+            </a:r>
+            <a:r>
+              <a:rPr lang="ru-RU" b="1" i="0" dirty="0">
+                <a:effectLst/>
+                <a:latin typeface="Roboto" panose="02000000000000000000" pitchFamily="2" charset="0"/>
+                <a:ea typeface="Roboto" panose="02000000000000000000" pitchFamily="2" charset="0"/>
+              </a:rPr>
+              <a:t>+ </a:t>
+            </a:r>
+            <a:r>
+              <a:rPr lang="en-US" b="1" i="0" dirty="0">
+                <a:effectLst/>
+                <a:latin typeface="Roboto" panose="02000000000000000000" pitchFamily="2" charset="0"/>
+                <a:ea typeface="Roboto" panose="02000000000000000000" pitchFamily="2" charset="0"/>
+              </a:rPr>
+              <a:t>Playwright</a:t>
+            </a:r>
+            <a:r>
+              <a:rPr lang="ru-RU" b="1" i="0" dirty="0">
+                <a:effectLst/>
+                <a:latin typeface="Roboto" panose="02000000000000000000" pitchFamily="2" charset="0"/>
+                <a:ea typeface="Roboto" panose="02000000000000000000" pitchFamily="2" charset="0"/>
+              </a:rPr>
+              <a:t> +</a:t>
+            </a:r>
+            <a:r>
+              <a:rPr lang="en-US" b="1" i="0" dirty="0">
+                <a:effectLst/>
+                <a:latin typeface="Roboto" panose="02000000000000000000" pitchFamily="2" charset="0"/>
+                <a:ea typeface="Roboto" panose="02000000000000000000" pitchFamily="2" charset="0"/>
+              </a:rPr>
+              <a:t> requests</a:t>
+            </a:r>
+            <a:r>
+              <a:rPr lang="ru-RU" b="1" i="0" dirty="0">
+                <a:effectLst/>
+                <a:latin typeface="Roboto" panose="02000000000000000000" pitchFamily="2" charset="0"/>
+                <a:ea typeface="Roboto" panose="02000000000000000000" pitchFamily="2" charset="0"/>
+              </a:rPr>
+              <a:t> + </a:t>
+            </a:r>
+            <a:r>
+              <a:rPr lang="en-US" b="1" i="0" dirty="0">
+                <a:effectLst/>
+                <a:latin typeface="Roboto" panose="02000000000000000000" pitchFamily="2" charset="0"/>
+                <a:ea typeface="Roboto" panose="02000000000000000000" pitchFamily="2" charset="0"/>
+              </a:rPr>
+              <a:t>BS4 </a:t>
+            </a:r>
+            <a:br>
+              <a:rPr lang="ru-RU" b="1" i="0" dirty="0">
+                <a:effectLst/>
+                <a:latin typeface="Roboto" panose="02000000000000000000" pitchFamily="2" charset="0"/>
+                <a:ea typeface="Roboto" panose="02000000000000000000" pitchFamily="2" charset="0"/>
+              </a:rPr>
+            </a:br>
+            <a:br>
+              <a:rPr lang="ru-RU" b="1" dirty="0">
+                <a:latin typeface="Roboto" panose="02000000000000000000" pitchFamily="2" charset="0"/>
+                <a:ea typeface="Roboto" panose="02000000000000000000" pitchFamily="2" charset="0"/>
+              </a:rPr>
+            </a:br>
+            <a:endParaRPr lang="ru-RU" b="1" dirty="0">
+              <a:latin typeface="Roboto" panose="02000000000000000000" pitchFamily="2" charset="0"/>
+              <a:ea typeface="Roboto" panose="02000000000000000000" pitchFamily="2" charset="0"/>
+            </a:endParaRPr>
+          </a:p>
+          <a:p>
+            <a:pPr algn="just"/>
+            <a:br>
+              <a:rPr lang="ru-RU" b="1" i="0" dirty="0">
+                <a:effectLst/>
+                <a:latin typeface="Roboto" panose="02000000000000000000" pitchFamily="2" charset="0"/>
+                <a:ea typeface="Roboto" panose="02000000000000000000" pitchFamily="2" charset="0"/>
+              </a:rPr>
+            </a:br>
+            <a:r>
+              <a:rPr lang="en-US" b="1" i="0" dirty="0" err="1">
+                <a:effectLst/>
+                <a:latin typeface="Roboto" panose="02000000000000000000" pitchFamily="2" charset="0"/>
+                <a:ea typeface="Roboto" panose="02000000000000000000" pitchFamily="2" charset="0"/>
+              </a:rPr>
+              <a:t>BERTopic</a:t>
+            </a:r>
+            <a:r>
+              <a:rPr lang="ru-RU" b="1" i="0" dirty="0">
+                <a:effectLst/>
+                <a:latin typeface="Roboto" panose="02000000000000000000" pitchFamily="2" charset="0"/>
+                <a:ea typeface="Roboto" panose="02000000000000000000" pitchFamily="2" charset="0"/>
+              </a:rPr>
+              <a:t> + </a:t>
+            </a:r>
+            <a:r>
+              <a:rPr lang="en-US" b="1" i="0" dirty="0">
+                <a:effectLst/>
+                <a:latin typeface="Roboto" panose="02000000000000000000" pitchFamily="2" charset="0"/>
+                <a:ea typeface="Roboto" panose="02000000000000000000" pitchFamily="2" charset="0"/>
+              </a:rPr>
+              <a:t>scikit-learn + </a:t>
+            </a:r>
+            <a:r>
+              <a:rPr lang="en-US" b="1" i="0" dirty="0" err="1">
+                <a:effectLst/>
+                <a:latin typeface="Roboto" panose="02000000000000000000" pitchFamily="2" charset="0"/>
+                <a:ea typeface="Roboto" panose="02000000000000000000" pitchFamily="2" charset="0"/>
+              </a:rPr>
+              <a:t>PyTorch</a:t>
+            </a:r>
+            <a:r>
+              <a:rPr lang="en-US" b="1" i="0" dirty="0">
+                <a:effectLst/>
+                <a:latin typeface="Roboto" panose="02000000000000000000" pitchFamily="2" charset="0"/>
+                <a:ea typeface="Roboto" panose="02000000000000000000" pitchFamily="2" charset="0"/>
+              </a:rPr>
+              <a:t> </a:t>
+            </a:r>
+            <a:br>
+              <a:rPr lang="ru-RU" b="1" i="0" dirty="0">
+                <a:effectLst/>
+                <a:latin typeface="Roboto" panose="02000000000000000000" pitchFamily="2" charset="0"/>
+                <a:ea typeface="Roboto" panose="02000000000000000000" pitchFamily="2" charset="0"/>
+              </a:rPr>
+            </a:br>
+            <a:endParaRPr lang="ru-RU" b="1" dirty="0">
+              <a:latin typeface="Roboto" panose="02000000000000000000" pitchFamily="2" charset="0"/>
+              <a:ea typeface="Roboto" panose="02000000000000000000" pitchFamily="2" charset="0"/>
+            </a:endParaRPr>
+          </a:p>
+        </p:txBody>
+      </p:sp>
+      <p:sp>
+        <p:nvSpPr>
+          <p:cNvPr id="12" name="Прямоугольник: скругленные углы 11">
+            <a:extLst>
+              <a:ext uri="{FF2B5EF4-FFF2-40B4-BE49-F238E27FC236}">
+                <a16:creationId xmlns:a16="http://schemas.microsoft.com/office/drawing/2014/main" id="{D1837C3B-E60C-4051-B0BC-5D6EFE3A09CF}"/>
+              </a:ext>
+            </a:extLst>
+          </p:cNvPr>
+          <p:cNvSpPr/>
+          <p:nvPr/>
+        </p:nvSpPr>
+        <p:spPr>
+          <a:xfrm>
+            <a:off x="1008643" y="1418849"/>
+            <a:ext cx="2648955" cy="442036"/>
+          </a:xfrm>
+          <a:prstGeom prst="roundRect">
+            <a:avLst/>
+          </a:prstGeom>
+        </p:spPr>
+        <p:style>
+          <a:lnRef idx="2">
+            <a:schemeClr val="accent1">
+              <a:shade val="50000"/>
+            </a:schemeClr>
+          </a:lnRef>
+          <a:fillRef idx="1">
+            <a:schemeClr val="accent1"/>
+          </a:fillRef>
+          <a:effectRef idx="0">
+            <a:schemeClr val="accent1"/>
+          </a:effectRef>
+          <a:fontRef idx="minor">
+            <a:schemeClr val="lt1"/>
+          </a:fontRef>
+        </p:style>
+        <p:txBody>
+          <a:bodyPr rtlCol="0" anchor="ctr"/>
+          <a:lstStyle/>
+          <a:p>
+            <a:pPr algn="ctr"/>
+            <a:r>
+              <a:rPr lang="ru-RU" b="1" dirty="0">
+                <a:latin typeface="Roboto" panose="02000000000000000000" pitchFamily="2" charset="0"/>
+                <a:ea typeface="Roboto" panose="02000000000000000000" pitchFamily="2" charset="0"/>
+              </a:rPr>
+              <a:t>Сбор данных</a:t>
+            </a:r>
+          </a:p>
+        </p:txBody>
+      </p:sp>
+      <p:sp>
+        <p:nvSpPr>
+          <p:cNvPr id="14" name="Прямоугольник: скругленные углы 13">
+            <a:extLst>
+              <a:ext uri="{FF2B5EF4-FFF2-40B4-BE49-F238E27FC236}">
+                <a16:creationId xmlns:a16="http://schemas.microsoft.com/office/drawing/2014/main" id="{FE35E1FA-B0B8-4CB2-86FD-4A7348196943}"/>
+              </a:ext>
+            </a:extLst>
+          </p:cNvPr>
+          <p:cNvSpPr/>
+          <p:nvPr/>
+        </p:nvSpPr>
+        <p:spPr>
+          <a:xfrm>
+            <a:off x="1008643" y="2473757"/>
+            <a:ext cx="2648955" cy="442036"/>
+          </a:xfrm>
+          <a:prstGeom prst="roundRect">
+            <a:avLst/>
+          </a:prstGeom>
+        </p:spPr>
+        <p:style>
+          <a:lnRef idx="2">
+            <a:schemeClr val="accent1">
+              <a:shade val="50000"/>
+            </a:schemeClr>
+          </a:lnRef>
+          <a:fillRef idx="1">
+            <a:schemeClr val="accent1"/>
+          </a:fillRef>
+          <a:effectRef idx="0">
+            <a:schemeClr val="accent1"/>
+          </a:effectRef>
+          <a:fontRef idx="minor">
+            <a:schemeClr val="lt1"/>
+          </a:fontRef>
+        </p:style>
+        <p:txBody>
+          <a:bodyPr rtlCol="0" anchor="ctr"/>
+          <a:lstStyle/>
+          <a:p>
+            <a:pPr algn="ctr"/>
+            <a:r>
+              <a:rPr lang="ru-RU" b="1" i="0" dirty="0">
+                <a:effectLst/>
+                <a:latin typeface="Roboto" panose="02000000000000000000" pitchFamily="2" charset="0"/>
+                <a:ea typeface="Roboto" panose="02000000000000000000" pitchFamily="2" charset="0"/>
+              </a:rPr>
+              <a:t>Анализ</a:t>
+            </a:r>
+            <a:r>
+              <a:rPr lang="ru-RU" b="1" dirty="0">
+                <a:latin typeface="Roboto" panose="02000000000000000000" pitchFamily="2" charset="0"/>
+                <a:ea typeface="Roboto" panose="02000000000000000000" pitchFamily="2" charset="0"/>
+              </a:rPr>
+              <a:t> данных</a:t>
+            </a:r>
+          </a:p>
+        </p:txBody>
+      </p:sp>
+      <p:sp>
+        <p:nvSpPr>
+          <p:cNvPr id="15" name="Прямоугольник: скругленные углы 14">
+            <a:extLst>
+              <a:ext uri="{FF2B5EF4-FFF2-40B4-BE49-F238E27FC236}">
+                <a16:creationId xmlns:a16="http://schemas.microsoft.com/office/drawing/2014/main" id="{D5129DEA-775D-4AD7-9F37-E824BE5CC544}"/>
+              </a:ext>
+            </a:extLst>
+          </p:cNvPr>
+          <p:cNvSpPr/>
+          <p:nvPr/>
+        </p:nvSpPr>
+        <p:spPr>
+          <a:xfrm>
+            <a:off x="7281106" y="1418849"/>
+            <a:ext cx="2648955" cy="442036"/>
+          </a:xfrm>
+          <a:prstGeom prst="roundRect">
+            <a:avLst/>
+          </a:prstGeom>
+        </p:spPr>
+        <p:style>
+          <a:lnRef idx="2">
+            <a:schemeClr val="accent1">
+              <a:shade val="50000"/>
+            </a:schemeClr>
+          </a:lnRef>
+          <a:fillRef idx="1">
+            <a:schemeClr val="accent1"/>
+          </a:fillRef>
+          <a:effectRef idx="0">
+            <a:schemeClr val="accent1"/>
+          </a:effectRef>
+          <a:fontRef idx="minor">
+            <a:schemeClr val="lt1"/>
+          </a:fontRef>
+        </p:style>
+        <p:txBody>
+          <a:bodyPr rtlCol="0" anchor="ctr"/>
+          <a:lstStyle/>
+          <a:p>
+            <a:pPr algn="ctr"/>
+            <a:r>
+              <a:rPr lang="ru-RU" b="1" i="0" dirty="0">
+                <a:effectLst/>
+                <a:latin typeface="Roboto" panose="02000000000000000000" pitchFamily="2" charset="0"/>
+                <a:ea typeface="Roboto" panose="02000000000000000000" pitchFamily="2" charset="0"/>
+              </a:rPr>
+              <a:t>Архитектура</a:t>
+            </a:r>
+            <a:endParaRPr lang="ru-RU" b="1" dirty="0">
+              <a:latin typeface="Roboto" panose="02000000000000000000" pitchFamily="2" charset="0"/>
+              <a:ea typeface="Roboto" panose="02000000000000000000" pitchFamily="2" charset="0"/>
+            </a:endParaRPr>
+          </a:p>
+        </p:txBody>
+      </p:sp>
+      <p:sp>
+        <p:nvSpPr>
+          <p:cNvPr id="16" name="Прямоугольник: скругленные углы 15">
+            <a:extLst>
+              <a:ext uri="{FF2B5EF4-FFF2-40B4-BE49-F238E27FC236}">
+                <a16:creationId xmlns:a16="http://schemas.microsoft.com/office/drawing/2014/main" id="{99AB96DF-0520-449B-B902-181E49DEF3DB}"/>
+              </a:ext>
+            </a:extLst>
+          </p:cNvPr>
+          <p:cNvSpPr/>
+          <p:nvPr/>
+        </p:nvSpPr>
+        <p:spPr>
+          <a:xfrm>
+            <a:off x="7281105" y="2473757"/>
+            <a:ext cx="2648955" cy="442036"/>
+          </a:xfrm>
+          <a:prstGeom prst="roundRect">
+            <a:avLst/>
+          </a:prstGeom>
+        </p:spPr>
+        <p:style>
+          <a:lnRef idx="2">
+            <a:schemeClr val="accent1">
+              <a:shade val="50000"/>
+            </a:schemeClr>
+          </a:lnRef>
+          <a:fillRef idx="1">
+            <a:schemeClr val="accent1"/>
+          </a:fillRef>
+          <a:effectRef idx="0">
+            <a:schemeClr val="accent1"/>
+          </a:effectRef>
+          <a:fontRef idx="minor">
+            <a:schemeClr val="lt1"/>
+          </a:fontRef>
+        </p:style>
+        <p:txBody>
+          <a:bodyPr rtlCol="0" anchor="ctr"/>
+          <a:lstStyle/>
+          <a:p>
+            <a:pPr algn="ctr"/>
+            <a:r>
+              <a:rPr lang="ru-RU" b="1" i="0" dirty="0">
+                <a:effectLst/>
+                <a:latin typeface="Roboto" panose="02000000000000000000" pitchFamily="2" charset="0"/>
+                <a:ea typeface="Roboto" panose="02000000000000000000" pitchFamily="2" charset="0"/>
+              </a:rPr>
+              <a:t>База</a:t>
+            </a:r>
+            <a:r>
+              <a:rPr lang="ru-RU" b="1" dirty="0">
+                <a:latin typeface="Roboto" panose="02000000000000000000" pitchFamily="2" charset="0"/>
+                <a:ea typeface="Roboto" panose="02000000000000000000" pitchFamily="2" charset="0"/>
+              </a:rPr>
+              <a:t> данных</a:t>
+            </a:r>
+          </a:p>
+        </p:txBody>
+      </p:sp>
+      <p:sp>
+        <p:nvSpPr>
+          <p:cNvPr id="17" name="Прямоугольник: скругленные углы 16">
+            <a:extLst>
+              <a:ext uri="{FF2B5EF4-FFF2-40B4-BE49-F238E27FC236}">
+                <a16:creationId xmlns:a16="http://schemas.microsoft.com/office/drawing/2014/main" id="{48848947-3393-413C-BA6D-BB56CA3C9583}"/>
+              </a:ext>
+            </a:extLst>
+          </p:cNvPr>
+          <p:cNvSpPr/>
+          <p:nvPr/>
+        </p:nvSpPr>
+        <p:spPr>
+          <a:xfrm>
+            <a:off x="7281106" y="3429000"/>
+            <a:ext cx="2648955" cy="442036"/>
+          </a:xfrm>
+          <a:prstGeom prst="roundRect">
+            <a:avLst/>
+          </a:prstGeom>
+        </p:spPr>
+        <p:style>
+          <a:lnRef idx="2">
+            <a:schemeClr val="accent1">
+              <a:shade val="50000"/>
+            </a:schemeClr>
+          </a:lnRef>
+          <a:fillRef idx="1">
+            <a:schemeClr val="accent1"/>
+          </a:fillRef>
+          <a:effectRef idx="0">
+            <a:schemeClr val="accent1"/>
+          </a:effectRef>
+          <a:fontRef idx="minor">
+            <a:schemeClr val="lt1"/>
+          </a:fontRef>
+        </p:style>
+        <p:txBody>
+          <a:bodyPr rtlCol="0" anchor="ctr"/>
+          <a:lstStyle/>
+          <a:p>
+            <a:pPr algn="ctr"/>
+            <a:r>
+              <a:rPr lang="ru-RU" b="1" i="0" dirty="0">
+                <a:effectLst/>
+                <a:latin typeface="Roboto" panose="02000000000000000000" pitchFamily="2" charset="0"/>
+                <a:ea typeface="Roboto" panose="02000000000000000000" pitchFamily="2" charset="0"/>
+              </a:rPr>
+              <a:t>Вывод</a:t>
+            </a:r>
+            <a:r>
+              <a:rPr lang="ru-RU" b="1" dirty="0">
+                <a:latin typeface="Roboto" panose="02000000000000000000" pitchFamily="2" charset="0"/>
+                <a:ea typeface="Roboto" panose="02000000000000000000" pitchFamily="2" charset="0"/>
+              </a:rPr>
+              <a:t> данных</a:t>
+            </a:r>
+          </a:p>
+        </p:txBody>
+      </p:sp>
+      <p:sp>
+        <p:nvSpPr>
+          <p:cNvPr id="19" name="TextBox 18">
+            <a:extLst>
+              <a:ext uri="{FF2B5EF4-FFF2-40B4-BE49-F238E27FC236}">
+                <a16:creationId xmlns:a16="http://schemas.microsoft.com/office/drawing/2014/main" id="{780BDB9E-A8F9-4D1B-AF0C-2B7143576240}"/>
+              </a:ext>
+            </a:extLst>
+          </p:cNvPr>
+          <p:cNvSpPr txBox="1"/>
+          <p:nvPr/>
+        </p:nvSpPr>
+        <p:spPr>
+          <a:xfrm>
+            <a:off x="7147538" y="2987730"/>
+            <a:ext cx="2916088" cy="369332"/>
+          </a:xfrm>
+          <a:prstGeom prst="rect">
+            <a:avLst/>
+          </a:prstGeom>
+          <a:noFill/>
+        </p:spPr>
+        <p:txBody>
+          <a:bodyPr wrap="square">
+            <a:spAutoFit/>
+          </a:bodyPr>
+          <a:lstStyle/>
+          <a:p>
+            <a:pPr algn="just"/>
+            <a:r>
+              <a:rPr lang="en-US" b="1" i="0" dirty="0" err="1">
+                <a:effectLst/>
+                <a:latin typeface="Roboto" panose="02000000000000000000" pitchFamily="2" charset="0"/>
+                <a:ea typeface="Roboto" panose="02000000000000000000" pitchFamily="2" charset="0"/>
+              </a:rPr>
+              <a:t>SQLAlchemy</a:t>
+            </a:r>
+            <a:r>
+              <a:rPr lang="en-US" b="1" i="0" dirty="0">
+                <a:effectLst/>
+                <a:latin typeface="Roboto" panose="02000000000000000000" pitchFamily="2" charset="0"/>
+                <a:ea typeface="Roboto" panose="02000000000000000000" pitchFamily="2" charset="0"/>
+              </a:rPr>
+              <a:t> </a:t>
+            </a:r>
+            <a:r>
+              <a:rPr lang="ru-RU" b="1" i="0" dirty="0">
+                <a:effectLst/>
+                <a:latin typeface="Roboto" panose="02000000000000000000" pitchFamily="2" charset="0"/>
+                <a:ea typeface="Roboto" panose="02000000000000000000" pitchFamily="2" charset="0"/>
+              </a:rPr>
+              <a:t>+ </a:t>
+            </a:r>
+            <a:r>
+              <a:rPr lang="en-US" b="1" i="0" dirty="0">
+                <a:effectLst/>
+                <a:latin typeface="Roboto" panose="02000000000000000000" pitchFamily="2" charset="0"/>
+                <a:ea typeface="Roboto" panose="02000000000000000000" pitchFamily="2" charset="0"/>
+              </a:rPr>
+              <a:t>PostgreSQL</a:t>
+            </a:r>
+            <a:endParaRPr lang="ru-RU" b="1" i="0" dirty="0">
+              <a:effectLst/>
+              <a:latin typeface="Roboto" panose="02000000000000000000" pitchFamily="2" charset="0"/>
+              <a:ea typeface="Roboto" panose="02000000000000000000" pitchFamily="2" charset="0"/>
+            </a:endParaRPr>
+          </a:p>
+        </p:txBody>
+      </p:sp>
+      <p:sp>
+        <p:nvSpPr>
+          <p:cNvPr id="21" name="TextBox 20">
+            <a:extLst>
+              <a:ext uri="{FF2B5EF4-FFF2-40B4-BE49-F238E27FC236}">
+                <a16:creationId xmlns:a16="http://schemas.microsoft.com/office/drawing/2014/main" id="{67642655-F4B4-48D4-9184-E0392C937FA9}"/>
+              </a:ext>
+            </a:extLst>
+          </p:cNvPr>
+          <p:cNvSpPr txBox="1"/>
+          <p:nvPr/>
+        </p:nvSpPr>
+        <p:spPr>
+          <a:xfrm>
+            <a:off x="8051126" y="3994357"/>
+            <a:ext cx="1108911" cy="369332"/>
+          </a:xfrm>
+          <a:prstGeom prst="rect">
+            <a:avLst/>
+          </a:prstGeom>
+          <a:noFill/>
+        </p:spPr>
+        <p:txBody>
+          <a:bodyPr wrap="square">
+            <a:spAutoFit/>
+          </a:bodyPr>
+          <a:lstStyle/>
+          <a:p>
+            <a:r>
+              <a:rPr lang="en-US" b="1" i="0" dirty="0" err="1">
+                <a:effectLst/>
+                <a:latin typeface="Roboto" panose="02000000000000000000" pitchFamily="2" charset="0"/>
+                <a:ea typeface="Roboto" panose="02000000000000000000" pitchFamily="2" charset="0"/>
+              </a:rPr>
+              <a:t>aiogram</a:t>
+            </a:r>
+            <a:endParaRPr lang="ru-RU" dirty="0"/>
+          </a:p>
+        </p:txBody>
+      </p:sp>
+      <p:sp>
+        <p:nvSpPr>
+          <p:cNvPr id="23" name="TextBox 22">
+            <a:extLst>
+              <a:ext uri="{FF2B5EF4-FFF2-40B4-BE49-F238E27FC236}">
+                <a16:creationId xmlns:a16="http://schemas.microsoft.com/office/drawing/2014/main" id="{3C2E8467-115C-4EA7-9310-5EE3D88F9237}"/>
+              </a:ext>
+            </a:extLst>
+          </p:cNvPr>
+          <p:cNvSpPr txBox="1"/>
+          <p:nvPr/>
+        </p:nvSpPr>
+        <p:spPr>
+          <a:xfrm>
+            <a:off x="7198494" y="1971980"/>
+            <a:ext cx="2814174" cy="369332"/>
+          </a:xfrm>
+          <a:prstGeom prst="rect">
+            <a:avLst/>
+          </a:prstGeom>
+          <a:noFill/>
+        </p:spPr>
+        <p:txBody>
+          <a:bodyPr wrap="square">
+            <a:spAutoFit/>
+          </a:bodyPr>
+          <a:lstStyle/>
+          <a:p>
+            <a:pPr algn="just"/>
+            <a:r>
+              <a:rPr lang="en-US" b="1" i="0" dirty="0">
+                <a:effectLst/>
+                <a:latin typeface="Roboto" panose="02000000000000000000" pitchFamily="2" charset="0"/>
+                <a:ea typeface="Roboto" panose="02000000000000000000" pitchFamily="2" charset="0"/>
+              </a:rPr>
+              <a:t>Async  </a:t>
+            </a:r>
+            <a:r>
+              <a:rPr lang="ru-RU" b="1" i="0" dirty="0">
+                <a:effectLst/>
+                <a:latin typeface="Roboto" panose="02000000000000000000" pitchFamily="2" charset="0"/>
+                <a:ea typeface="Roboto" panose="02000000000000000000" pitchFamily="2" charset="0"/>
+              </a:rPr>
+              <a:t>+ </a:t>
+            </a:r>
+            <a:r>
+              <a:rPr lang="en-US" b="1" i="0" dirty="0">
+                <a:effectLst/>
+                <a:latin typeface="Roboto" panose="02000000000000000000" pitchFamily="2" charset="0"/>
+                <a:ea typeface="Roboto" panose="02000000000000000000" pitchFamily="2" charset="0"/>
+              </a:rPr>
+              <a:t>Multithreading</a:t>
+            </a:r>
+            <a:endParaRPr lang="ru-RU" b="1" i="0" dirty="0">
+              <a:effectLst/>
+              <a:latin typeface="Roboto" panose="02000000000000000000" pitchFamily="2" charset="0"/>
+              <a:ea typeface="Roboto" panose="02000000000000000000" pitchFamily="2" charset="0"/>
+            </a:endParaRPr>
+          </a:p>
+        </p:txBody>
+      </p:sp>
+    </p:spTree>
+    <p:extLst>
+      <p:ext uri="{BB962C8B-B14F-4D97-AF65-F5344CB8AC3E}">
+        <p14:creationId xmlns:p14="http://schemas.microsoft.com/office/powerpoint/2010/main" val="3537816777"/>
+      </p:ext>
+    </p:extLst>
+  </p:cSld>
+  <p:clrMapOvr>
+    <a:masterClrMapping/>
+  </p:clrMapOvr>
+</p:sld>
+</file>
+
+<file path=ppt/slides/slide6.xml><?xml version="1.0" encoding="utf-8"?>
+<p:sld xmlns:a="http://schemas.openxmlformats.org/drawingml/2006/main" xmlns:r="http://schemas.openxmlformats.org/officeDocument/2006/relationships" xmlns:p="http://schemas.openxmlformats.org/presentationml/2006/main">
+  <p:cSld>
+    <p:spTree>
+      <p:nvGrpSpPr>
+        <p:cNvPr id="1" name=""/>
+        <p:cNvGrpSpPr/>
+        <p:nvPr/>
+      </p:nvGrpSpPr>
+      <p:grpSpPr>
+        <a:xfrm>
+          <a:off x="0" y="0"/>
+          <a:ext cx="0" cy="0"/>
+          <a:chOff x="0" y="0"/>
+          <a:chExt cx="0" cy="0"/>
+        </a:xfrm>
+      </p:grpSpPr>
+      <p:sp>
+        <p:nvSpPr>
           <p:cNvPr id="5" name="Прямоугольник 4">
             <a:extLst>
               <a:ext uri="{FF2B5EF4-FFF2-40B4-BE49-F238E27FC236}">
@@ -4918,7 +5622,7 @@
 </p:sld>
 </file>
 
-<file path=ppt/slides/slide6.xml><?xml version="1.0" encoding="utf-8"?>
+<file path=ppt/slides/slide7.xml><?xml version="1.0" encoding="utf-8"?>
 <p:sld xmlns:a="http://schemas.openxmlformats.org/drawingml/2006/main" xmlns:r="http://schemas.openxmlformats.org/officeDocument/2006/relationships" xmlns:p="http://schemas.openxmlformats.org/presentationml/2006/main">
   <p:cSld>
     <p:spTree>

</xml_diff>